<commit_message>
fix(slides): embed trajectory vs ground truth figures for ORB and SIFT
Co-Authored-By: Claude Sonnet 4.6 <noreply@anthropic.com>
</commit_message>
<xml_diff>
--- a/VO_Robustness_Slides.pptx
+++ b/VO_Robustness_Slides.pptx
@@ -10856,12 +10856,20 @@
           </a:p>
         </p:txBody>
       </p:sp>
-      <p:sp>
-        <p:nvSpPr>
-          <p:cNvPr id="5" name="Rectangle 4"/>
-          <p:cNvSpPr/>
-          <p:nvPr/>
-        </p:nvSpPr>
+      <p:pic>
+        <p:nvPicPr>
+          <p:cNvPr id="5" name="Picture 4" descr="traj_ORB.png"/>
+          <p:cNvPicPr>
+            <a:picLocks noChangeAspect="1"/>
+          </p:cNvPicPr>
+          <p:nvPr/>
+        </p:nvPicPr>
+        <p:blipFill>
+          <a:blip r:embed="rId2"/>
+          <a:stretch>
+            <a:fillRect/>
+          </a:stretch>
+        </p:blipFill>
         <p:spPr>
           <a:xfrm>
             <a:off x="365760" y="1097280"/>
@@ -10870,66 +10878,22 @@
           <a:prstGeom prst="rect">
             <a:avLst/>
           </a:prstGeom>
-          <a:solidFill>
-            <a:srgbClr val="E8E9EC"/>
-          </a:solidFill>
-          <a:ln w="19050">
-            <a:solidFill>
-              <a:srgbClr val="999AA8"/>
-            </a:solidFill>
-            <a:prstDash val="dash"/>
-          </a:ln>
-        </p:spPr>
-        <p:style>
-          <a:lnRef idx="1">
-            <a:schemeClr val="accent1"/>
-          </a:lnRef>
-          <a:fillRef idx="3">
-            <a:schemeClr val="accent1"/>
-          </a:fillRef>
-          <a:effectRef idx="2">
-            <a:schemeClr val="accent1"/>
-          </a:effectRef>
-          <a:fontRef idx="minor">
-            <a:schemeClr val="lt1"/>
-          </a:fontRef>
-        </p:style>
-        <p:txBody>
-          <a:bodyPr rtlCol="0" anchor="ctr" wrap="square"/>
-          <a:lstStyle/>
-          <a:p>
-            <a:pPr algn="ctr"/>
-            <a:r>
-              <a:rPr sz="1600" b="1">
-                <a:solidFill>
-                  <a:srgbClr val="555670"/>
-                </a:solidFill>
-                <a:latin typeface="Calibri"/>
-              </a:rPr>
-              <a:t>[ FIGURE: ORB trajectory ]</a:t>
-            </a:r>
-          </a:p>
-          <a:p>
-            <a:pPr algn="ctr"/>
-            <a:r>
-              <a:rPr sz="1200">
-                <a:solidFill>
-                  <a:srgbClr val="8889A0"/>
-                </a:solidFill>
-                <a:latin typeface="Calibri"/>
-              </a:rPr>
-              <a:t>XY top-down view of estimated path (colored by degradation) vs GT (black)
-Generate with evo_traj or matplotlib from results/trajectories/{seq}__ORB__*.tum</a:t>
-            </a:r>
-          </a:p>
-        </p:txBody>
-      </p:sp>
-      <p:sp>
-        <p:nvSpPr>
-          <p:cNvPr id="6" name="Rectangle 5"/>
-          <p:cNvSpPr/>
-          <p:nvPr/>
-        </p:nvSpPr>
+        </p:spPr>
+      </p:pic>
+      <p:pic>
+        <p:nvPicPr>
+          <p:cNvPr id="6" name="Picture 5" descr="traj_SIFT.png"/>
+          <p:cNvPicPr>
+            <a:picLocks noChangeAspect="1"/>
+          </p:cNvPicPr>
+          <p:nvPr/>
+        </p:nvPicPr>
+        <p:blipFill>
+          <a:blip r:embed="rId3"/>
+          <a:stretch>
+            <a:fillRect/>
+          </a:stretch>
+        </p:blipFill>
         <p:spPr>
           <a:xfrm>
             <a:off x="6309360" y="1097280"/>
@@ -10938,60 +10902,8 @@
           <a:prstGeom prst="rect">
             <a:avLst/>
           </a:prstGeom>
-          <a:solidFill>
-            <a:srgbClr val="E8E9EC"/>
-          </a:solidFill>
-          <a:ln w="19050">
-            <a:solidFill>
-              <a:srgbClr val="999AA8"/>
-            </a:solidFill>
-            <a:prstDash val="dash"/>
-          </a:ln>
-        </p:spPr>
-        <p:style>
-          <a:lnRef idx="1">
-            <a:schemeClr val="accent1"/>
-          </a:lnRef>
-          <a:fillRef idx="3">
-            <a:schemeClr val="accent1"/>
-          </a:fillRef>
-          <a:effectRef idx="2">
-            <a:schemeClr val="accent1"/>
-          </a:effectRef>
-          <a:fontRef idx="minor">
-            <a:schemeClr val="lt1"/>
-          </a:fontRef>
-        </p:style>
-        <p:txBody>
-          <a:bodyPr rtlCol="0" anchor="ctr" wrap="square"/>
-          <a:lstStyle/>
-          <a:p>
-            <a:pPr algn="ctr"/>
-            <a:r>
-              <a:rPr sz="1600" b="1">
-                <a:solidFill>
-                  <a:srgbClr val="555670"/>
-                </a:solidFill>
-                <a:latin typeface="Calibri"/>
-              </a:rPr>
-              <a:t>[ FIGURE: SIFT trajectory ]</a:t>
-            </a:r>
-          </a:p>
-          <a:p>
-            <a:pPr algn="ctr"/>
-            <a:r>
-              <a:rPr sz="1200">
-                <a:solidFill>
-                  <a:srgbClr val="8889A0"/>
-                </a:solidFill>
-                <a:latin typeface="Calibri"/>
-              </a:rPr>
-              <a:t>XY top-down view of estimated path (colored by degradation) vs GT (black)
-Generate with evo_traj or matplotlib from results/trajectories/{seq}__SIFT__*.tum</a:t>
-            </a:r>
-          </a:p>
-        </p:txBody>
-      </p:sp>
+        </p:spPr>
+      </p:pic>
       <p:sp>
         <p:nvSpPr>
           <p:cNvPr id="7" name="TextBox 6"/>

</xml_diff>